<commit_message>
Add resumable extended rerun experiment and Colab notebook; combined submission PDF
scripts/extended.py reruns scanner-flagged tests 1,000 times across 10 time zones in
resumable chunks. colab/ holds the setup script, pinned requirements, and notebook.
Slide 5 timeline now matches the Canvas due dates.
</commit_message>
<xml_diff>
--- a/slides/Kapur_ECE382V_Initial_Idea.pptx
+++ b/slides/Kapur_ECE382V_Initial_Idea.pptx
@@ -111,7 +111,7 @@
   <p:extLst>
     <p:ext uri="{521415D9-36F7-43E2-AB2F-B90AF26B5E84}">
       <p14:sectionLst xmlns:p14="http://schemas.microsoft.com/office/powerpoint/2010/main">
-        <p14:section name="Idea" id="{ff435a2e-0c16-7cf2-2737-32ed789dd250}">
+        <p14:section name="Idea" id="{33b249f0-f2d7-4350-c649-09fbc3d59d1c}">
           <p14:sldIdLst>
             <p14:sldId id="256"/>
             <p14:sldId id="257"/>
@@ -119,7 +119,7 @@
             <p14:sldId id="259"/>
           </p14:sldIdLst>
         </p14:section>
-        <p14:section name="Plan" id="{36f3b153-6a51-5cbb-ca02-e1ceba0b76cd}">
+        <p14:section name="Plan" id="{e233e2df-dc9e-a4c9-1f80-9e87f48f7c4b}">
           <p14:sldIdLst>
             <p14:sldId id="260"/>
           </p14:sldIdLst>
@@ -5776,7 +5776,7 @@
                   <a:schemeClr val="bg2"/>
                 </a:solidFill>
               </a:rPr>
-              <a:t>Oct 24 more models and reruns</a:t>
+              <a:t>Oct 23 more models and reruns</a:t>
             </a:r>
             <a:endParaRPr lang="en-US" sz="1200" dirty="0"/>
           </a:p>
@@ -5794,7 +5794,7 @@
                   <a:schemeClr val="bg2"/>
                 </a:solidFill>
               </a:rPr>
-              <a:t>Nov 7 slower CI machine runs</a:t>
+              <a:t>Nov 6 slower CI machine runs</a:t>
             </a:r>
             <a:endParaRPr lang="en-US" sz="1200" dirty="0"/>
           </a:p>
@@ -5812,7 +5812,7 @@
                   <a:schemeClr val="bg2"/>
                 </a:solidFill>
               </a:rPr>
-              <a:t>Nov 21 mitigation prompt</a:t>
+              <a:t>Nov 20 mitigation prompt</a:t>
             </a:r>
             <a:endParaRPr lang="en-US" sz="1200" dirty="0"/>
           </a:p>

</xml_diff>